<commit_message>
Update PowerPoint for song #168 in FUBC - Українські
</commit_message>
<xml_diff>
--- a/fubc-ua/168-У гріхах я потопав (Пісні Спасенних №166).pptx
+++ b/fubc-ua/168-У гріхах я потопав (Пісні Спасенних №166).pptx
@@ -2069,23 +2069,6 @@
             </a:r>
             <a:endParaRPr lang="en-US" sz="5200" dirty="0"/>
           </a:p>
-          <a:p>
-            <a:pPr algn="ctr" indent="0" marL="0">
-              <a:buNone/>
-            </a:pPr>
-            <a:r>
-              <a:rPr lang="en-US" sz="5200" b="1" dirty="0">
-                <a:solidFill>
-                  <a:srgbClr val="FFFFFF"/>
-                </a:solidFill>
-                <a:latin typeface="Arial" pitchFamily="34" charset="0"/>
-                <a:ea typeface="Arial" pitchFamily="34" charset="-122"/>
-                <a:cs typeface="Arial" pitchFamily="34" charset="-120"/>
-              </a:rPr>
-              <a:t>(Пісні Спасенних №166)</a:t>
-            </a:r>
-            <a:endParaRPr lang="en-US" sz="5200" dirty="0"/>
-          </a:p>
         </p:txBody>
       </p:sp>
     </p:spTree>
@@ -2478,7 +2461,7 @@
                 <a:ea typeface="Arial" pitchFamily="34" charset="-122"/>
                 <a:cs typeface="Arial" pitchFamily="34" charset="-120"/>
               </a:rPr>
-              <a:t>Божа любов (спасла),</a:t>
+              <a:t>Божа любов,</a:t>
             </a:r>
             <a:endParaRPr lang="en-US" sz="5200" dirty="0"/>
           </a:p>
@@ -2532,7 +2515,7 @@
         </p:nvSpPr>
         <p:spPr>
           <a:xfrm>
-            <a:off x="2172640" y="2359152"/>
+            <a:off x="3627831" y="2359152"/>
             <a:ext cx="0" cy="594360"/>
           </a:xfrm>
           <a:prstGeom prst="line">
@@ -2555,7 +2538,7 @@
         </p:nvSpPr>
         <p:spPr>
           <a:xfrm>
-            <a:off x="10025456" y="2359152"/>
+            <a:off x="8570265" y="2359152"/>
             <a:ext cx="0" cy="594360"/>
           </a:xfrm>
           <a:prstGeom prst="line">
@@ -2578,7 +2561,7 @@
         </p:nvSpPr>
         <p:spPr>
           <a:xfrm>
-            <a:off x="10157536" y="2425192"/>
+            <a:off x="8702345" y="2425192"/>
             <a:ext cx="792480" cy="462280"/>
           </a:xfrm>
           <a:prstGeom prst="rect">
@@ -2677,7 +2660,7 @@
                 <a:ea typeface="Arial" pitchFamily="34" charset="-122"/>
                 <a:cs typeface="Arial" pitchFamily="34" charset="-120"/>
               </a:rPr>
-              <a:t>Божа любов (спасла),</a:t>
+              <a:t>Божа любов,</a:t>
             </a:r>
             <a:endParaRPr lang="en-US" sz="5200" dirty="0"/>
           </a:p>
@@ -2731,7 +2714,7 @@
         </p:nvSpPr>
         <p:spPr>
           <a:xfrm>
-            <a:off x="2172640" y="2359152"/>
+            <a:off x="3627831" y="2359152"/>
             <a:ext cx="0" cy="594360"/>
           </a:xfrm>
           <a:prstGeom prst="line">
@@ -2754,7 +2737,7 @@
         </p:nvSpPr>
         <p:spPr>
           <a:xfrm>
-            <a:off x="10025456" y="2359152"/>
+            <a:off x="8570265" y="2359152"/>
             <a:ext cx="0" cy="594360"/>
           </a:xfrm>
           <a:prstGeom prst="line">
@@ -2777,7 +2760,7 @@
         </p:nvSpPr>
         <p:spPr>
           <a:xfrm>
-            <a:off x="10157536" y="2425192"/>
+            <a:off x="8702345" y="2425192"/>
             <a:ext cx="792480" cy="462280"/>
           </a:xfrm>
           <a:prstGeom prst="rect">
@@ -3269,7 +3252,7 @@
                 <a:ea typeface="Arial" pitchFamily="34" charset="-122"/>
                 <a:cs typeface="Arial" pitchFamily="34" charset="-120"/>
               </a:rPr>
-              <a:t>Божа любов (спасла),</a:t>
+              <a:t>Божа любов,</a:t>
             </a:r>
             <a:endParaRPr lang="en-US" sz="5200" dirty="0"/>
           </a:p>
@@ -3323,7 +3306,7 @@
         </p:nvSpPr>
         <p:spPr>
           <a:xfrm>
-            <a:off x="2172640" y="2359152"/>
+            <a:off x="3627831" y="2359152"/>
             <a:ext cx="0" cy="594360"/>
           </a:xfrm>
           <a:prstGeom prst="line">
@@ -3346,7 +3329,7 @@
         </p:nvSpPr>
         <p:spPr>
           <a:xfrm>
-            <a:off x="10025456" y="2359152"/>
+            <a:off x="8570265" y="2359152"/>
             <a:ext cx="0" cy="594360"/>
           </a:xfrm>
           <a:prstGeom prst="line">
@@ -3369,7 +3352,7 @@
         </p:nvSpPr>
         <p:spPr>
           <a:xfrm>
-            <a:off x="10157536" y="2425192"/>
+            <a:off x="8702345" y="2425192"/>
             <a:ext cx="792480" cy="462280"/>
           </a:xfrm>
           <a:prstGeom prst="rect">
@@ -3468,7 +3451,7 @@
                 <a:ea typeface="Arial" pitchFamily="34" charset="-122"/>
                 <a:cs typeface="Arial" pitchFamily="34" charset="-120"/>
               </a:rPr>
-              <a:t>Божа любов (спасла),</a:t>
+              <a:t>Божа любов,</a:t>
             </a:r>
             <a:endParaRPr lang="en-US" sz="5200" dirty="0"/>
           </a:p>
@@ -3522,7 +3505,7 @@
         </p:nvSpPr>
         <p:spPr>
           <a:xfrm>
-            <a:off x="2172640" y="2359152"/>
+            <a:off x="3627831" y="2359152"/>
             <a:ext cx="0" cy="594360"/>
           </a:xfrm>
           <a:prstGeom prst="line">
@@ -3545,7 +3528,7 @@
         </p:nvSpPr>
         <p:spPr>
           <a:xfrm>
-            <a:off x="10025456" y="2359152"/>
+            <a:off x="8570265" y="2359152"/>
             <a:ext cx="0" cy="594360"/>
           </a:xfrm>
           <a:prstGeom prst="line">
@@ -3568,7 +3551,7 @@
         </p:nvSpPr>
         <p:spPr>
           <a:xfrm>
-            <a:off x="10157536" y="2425192"/>
+            <a:off x="8702345" y="2425192"/>
             <a:ext cx="792480" cy="462280"/>
           </a:xfrm>
           <a:prstGeom prst="rect">
@@ -3989,7 +3972,7 @@
                 <a:ea typeface="Arial" pitchFamily="34" charset="-122"/>
                 <a:cs typeface="Arial" pitchFamily="34" charset="-120"/>
               </a:rPr>
-              <a:t>Божа любов (спасла),</a:t>
+              <a:t>Божа любов,</a:t>
             </a:r>
             <a:endParaRPr lang="en-US" sz="5200" dirty="0"/>
           </a:p>
@@ -4043,7 +4026,7 @@
         </p:nvSpPr>
         <p:spPr>
           <a:xfrm>
-            <a:off x="2172640" y="2359152"/>
+            <a:off x="3627831" y="2359152"/>
             <a:ext cx="0" cy="594360"/>
           </a:xfrm>
           <a:prstGeom prst="line">
@@ -4066,7 +4049,7 @@
         </p:nvSpPr>
         <p:spPr>
           <a:xfrm>
-            <a:off x="10025456" y="2359152"/>
+            <a:off x="8570265" y="2359152"/>
             <a:ext cx="0" cy="594360"/>
           </a:xfrm>
           <a:prstGeom prst="line">
@@ -4089,7 +4072,7 @@
         </p:nvSpPr>
         <p:spPr>
           <a:xfrm>
-            <a:off x="10157536" y="2425192"/>
+            <a:off x="8702345" y="2425192"/>
             <a:ext cx="792480" cy="462280"/>
           </a:xfrm>
           <a:prstGeom prst="rect">
@@ -4188,7 +4171,7 @@
                 <a:ea typeface="Arial" pitchFamily="34" charset="-122"/>
                 <a:cs typeface="Arial" pitchFamily="34" charset="-120"/>
               </a:rPr>
-              <a:t>Божа любов (спасла),</a:t>
+              <a:t>Божа любов,</a:t>
             </a:r>
             <a:endParaRPr lang="en-US" sz="5200" dirty="0"/>
           </a:p>
@@ -4242,7 +4225,7 @@
         </p:nvSpPr>
         <p:spPr>
           <a:xfrm>
-            <a:off x="2172640" y="2359152"/>
+            <a:off x="3627831" y="2359152"/>
             <a:ext cx="0" cy="594360"/>
           </a:xfrm>
           <a:prstGeom prst="line">
@@ -4265,7 +4248,7 @@
         </p:nvSpPr>
         <p:spPr>
           <a:xfrm>
-            <a:off x="10025456" y="2359152"/>
+            <a:off x="8570265" y="2359152"/>
             <a:ext cx="0" cy="594360"/>
           </a:xfrm>
           <a:prstGeom prst="line">
@@ -4288,7 +4271,7 @@
         </p:nvSpPr>
         <p:spPr>
           <a:xfrm>
-            <a:off x="10157536" y="2425192"/>
+            <a:off x="8702345" y="2425192"/>
             <a:ext cx="792480" cy="462280"/>
           </a:xfrm>
           <a:prstGeom prst="rect">

</xml_diff>